<commit_message>
Add Entity Relationship Diagram slide to presentation
</commit_message>
<xml_diff>
--- a/SmartParking_ppt.pptx
+++ b/SmartParking_ppt.pptx
@@ -17,6 +17,7 @@
     <p:sldId id="262" r:id="rId10"/>
     <p:sldId id="263" r:id="rId11"/>
     <p:sldId id="264" r:id="rId12"/>
+    <p:sldId id="277" r:id="rId28"/>
     <p:sldId id="265" r:id="rId13"/>
     <p:sldId id="266" r:id="rId14"/>
     <p:sldId id="267" r:id="rId15"/>
@@ -5686,6 +5687,226 @@
           </a:p>
         </p:txBody>
       </p:sp>
+    </p:spTree>
+  </p:cSld>
+  <p:clrMapOvr>
+    <a:masterClrMapping/>
+  </p:clrMapOvr>
+</p:sld>
+</file>
+
+<file path=ppt/slides/slide22.xml><?xml version="1.0" encoding="utf-8"?>
+<p:sld xmlns:a="http://schemas.openxmlformats.org/drawingml/2006/main" xmlns:p="http://schemas.openxmlformats.org/presentationml/2006/main" xmlns:r="http://schemas.openxmlformats.org/officeDocument/2006/relationships">
+  <p:cSld>
+    <p:bg>
+      <p:bgPr>
+        <a:solidFill>
+          <a:srgbClr val="FFFFFF"/>
+        </a:solidFill>
+        <a:effectLst/>
+      </p:bgPr>
+    </p:bg>
+    <p:spTree>
+      <p:nvGrpSpPr>
+        <p:cNvPr id="1" name=""/>
+        <p:cNvGrpSpPr/>
+        <p:nvPr/>
+      </p:nvGrpSpPr>
+      <p:grpSpPr/>
+      <p:pic>
+        <p:nvPicPr>
+          <p:cNvPr id="2" name="Picture 1" descr="image.png"/>
+          <p:cNvPicPr>
+            <a:picLocks noChangeAspect="1"/>
+          </p:cNvPicPr>
+          <p:nvPr/>
+        </p:nvPicPr>
+        <p:blipFill>
+          <a:blip r:embed="rId2"/>
+          <a:stretch>
+            <a:fillRect/>
+          </a:stretch>
+        </p:blipFill>
+        <p:spPr>
+          <a:xfrm>
+            <a:off x="274320" y="4553712"/>
+            <a:ext cx="1005840" cy="402336"/>
+          </a:xfrm>
+          <a:prstGeom prst="rect">
+            <a:avLst/>
+          </a:prstGeom>
+        </p:spPr>
+      </p:pic>
+      <p:sp>
+        <p:nvSpPr>
+          <p:cNvPr id="3" name="Text 0"/>
+          <p:cNvSpPr txBox="1"/>
+          <p:nvPr/>
+        </p:nvSpPr>
+        <p:spPr>
+          <a:xfrm>
+            <a:off x="3200400" y="4910328"/>
+            <a:ext cx="2743200" cy="201168"/>
+          </a:xfrm>
+          <a:prstGeom prst="rect">
+            <a:avLst/>
+          </a:prstGeom>
+          <a:noFill/>
+        </p:spPr>
+        <p:txBody>
+          <a:bodyPr wrap="square">
+            <a:spAutoFit/>
+          </a:bodyPr>
+          <a:lstStyle/>
+          <a:p>
+            <a:pPr algn="ctr">
+              <a:defRPr/>
+            </a:pPr>
+            <a:r>
+              <a:rPr sz="800">
+                <a:solidFill>
+                  <a:srgbClr val="888888"/>
+                </a:solidFill>
+                <a:latin typeface="Arial"/>
+              </a:rPr>
+              <a:t>General - RPS Data</a:t>
+            </a:r>
+          </a:p>
+        </p:txBody>
+      </p:sp>
+      <p:sp>
+        <p:nvSpPr>
+          <p:cNvPr id="4" name="Text 1"/>
+          <p:cNvSpPr txBox="1"/>
+          <p:nvPr/>
+        </p:nvSpPr>
+        <p:spPr>
+          <a:xfrm>
+            <a:off x="5029200" y="4910328"/>
+            <a:ext cx="3931920" cy="201168"/>
+          </a:xfrm>
+          <a:prstGeom prst="rect">
+            <a:avLst/>
+          </a:prstGeom>
+          <a:noFill/>
+        </p:spPr>
+        <p:txBody>
+          <a:bodyPr wrap="square">
+            <a:spAutoFit/>
+          </a:bodyPr>
+          <a:lstStyle/>
+          <a:p>
+            <a:pPr algn="r">
+              <a:defRPr/>
+            </a:pPr>
+            <a:r>
+              <a:rPr sz="800">
+                <a:solidFill>
+                  <a:srgbClr val="888888"/>
+                </a:solidFill>
+                <a:latin typeface="Arial"/>
+              </a:rPr>
+              <a:t>2026 - RPS Consulting all rights reserved    2</a:t>
+            </a:r>
+          </a:p>
+        </p:txBody>
+      </p:sp>
+      <p:sp>
+        <p:nvSpPr>
+          <p:cNvPr id="5" name="Text 2"/>
+          <p:cNvSpPr txBox="1"/>
+          <p:nvPr/>
+        </p:nvSpPr>
+        <p:spPr>
+          <a:xfrm>
+            <a:off x="457200" y="228600"/>
+            <a:ext cx="8229600" cy="438912"/>
+          </a:xfrm>
+          <a:prstGeom prst="rect">
+            <a:avLst/>
+          </a:prstGeom>
+          <a:noFill/>
+        </p:spPr>
+        <p:txBody>
+          <a:bodyPr wrap="square" lIns="0" rIns="0" tIns="0" bIns="0">
+            <a:spAutoFit/>
+          </a:bodyPr>
+          <a:lstStyle/>
+          <a:p>
+            <a:pPr>
+              <a:defRPr/>
+            </a:pPr>
+            <a:r>
+              <a:rPr sz="2600" b="1">
+                <a:solidFill>
+                  <a:srgbClr val="0096CC"/>
+                </a:solidFill>
+                <a:latin typeface="Arial"/>
+              </a:rPr>
+              <a:t>Smart Parking Management System</a:t>
+            </a:r>
+          </a:p>
+        </p:txBody>
+      </p:sp>
+      <p:sp>
+        <p:nvSpPr>
+          <p:cNvPr id="6" name="Text 3"/>
+          <p:cNvSpPr txBox="1"/>
+          <p:nvPr/>
+        </p:nvSpPr>
+        <p:spPr>
+          <a:xfrm>
+            <a:off x="400685" y="823087"/>
+            <a:ext cx="8229600" cy="347472"/>
+          </a:xfrm>
+          <a:prstGeom prst="rect">
+            <a:avLst/>
+          </a:prstGeom>
+          <a:noFill/>
+        </p:spPr>
+        <p:txBody>
+          <a:bodyPr wrap="square" lIns="0" rIns="0" tIns="0" bIns="0">
+            <a:spAutoFit/>
+          </a:bodyPr>
+          <a:lstStyle/>
+          <a:p>
+            <a:pPr/>
+            <a:r>
+              <a:rPr sz="1800" b="1">
+                <a:solidFill>
+                  <a:srgbClr val="0096CC"/>
+                </a:solidFill>
+                <a:latin typeface="Arial"/>
+              </a:rPr>
+              <a:t>Entity Relationship Diagram</a:t>
+            </a:r>
+          </a:p>
+        </p:txBody>
+      </p:sp>
+      <p:pic>
+        <p:nvPicPr>
+          <p:cNvPr id="7" name="Picture 6" descr="ER_page_1.png"/>
+          <p:cNvPicPr>
+            <a:picLocks noChangeAspect="1"/>
+          </p:cNvPicPr>
+          <p:nvPr/>
+        </p:nvPicPr>
+        <p:blipFill>
+          <a:blip r:embed="rId3"/>
+          <a:stretch>
+            <a:fillRect/>
+          </a:stretch>
+        </p:blipFill>
+        <p:spPr>
+          <a:xfrm>
+            <a:off x="3504937" y="1403604"/>
+            <a:ext cx="2134124" cy="3017520"/>
+          </a:xfrm>
+          <a:prstGeom prst="rect">
+            <a:avLst/>
+          </a:prstGeom>
+        </p:spPr>
+      </p:pic>
     </p:spTree>
   </p:cSld>
   <p:clrMapOvr>

</xml_diff>

<commit_message>
Update ER Diagram with high-resolution clean version
</commit_message>
<xml_diff>
--- a/SmartParking_ppt.pptx
+++ b/SmartParking_ppt.pptx
@@ -17,7 +17,7 @@
     <p:sldId id="262" r:id="rId10"/>
     <p:sldId id="263" r:id="rId11"/>
     <p:sldId id="264" r:id="rId12"/>
-    <p:sldId id="277" r:id="rId28"/>
+    <p:sldId id="277" r:id="rId29"/>
     <p:sldId id="265" r:id="rId13"/>
     <p:sldId id="266" r:id="rId14"/>
     <p:sldId id="267" r:id="rId15"/>
@@ -2087,7 +2087,7 @@
 </file>
 
 <file path=ppt/slides/slide10.xml><?xml version="1.0" encoding="utf-8"?>
-<p:sld xmlns:a="http://schemas.openxmlformats.org/drawingml/2006/main" xmlns:r="http://schemas.openxmlformats.org/officeDocument/2006/relationships" xmlns:p="http://schemas.openxmlformats.org/presentationml/2006/main">
+<p:sld xmlns:a="http://schemas.openxmlformats.org/drawingml/2006/main" xmlns:p="http://schemas.openxmlformats.org/presentationml/2006/main" xmlns:r="http://schemas.openxmlformats.org/officeDocument/2006/relationships">
   <p:cSld>
     <p:bg>
       <p:bgPr>
@@ -2103,24 +2103,17 @@
         <p:cNvGrpSpPr/>
         <p:nvPr/>
       </p:nvGrpSpPr>
-      <p:grpSpPr>
-        <a:xfrm>
-          <a:off x="0" y="0"/>
-          <a:ext cx="0" cy="0"/>
-          <a:chOff x="0" y="0"/>
-          <a:chExt cx="0" cy="0"/>
-        </a:xfrm>
-      </p:grpSpPr>
+      <p:grpSpPr/>
       <p:pic>
         <p:nvPicPr>
-          <p:cNvPr id="2" name="Image 0" descr="preencoded.png"/>
+          <p:cNvPr id="2" name="Picture 1" descr="image.png"/>
           <p:cNvPicPr>
             <a:picLocks noChangeAspect="1"/>
           </p:cNvPicPr>
           <p:nvPr/>
         </p:nvPicPr>
         <p:blipFill>
-          <a:blip r:embed="rId1"/>
+          <a:blip r:embed="rId2"/>
           <a:stretch>
             <a:fillRect/>
           </a:stretch>
@@ -2138,7 +2131,7 @@
       <p:sp>
         <p:nvSpPr>
           <p:cNvPr id="3" name="Text 0"/>
-          <p:cNvSpPr/>
+          <p:cNvSpPr txBox="1"/>
           <p:nvPr/>
         </p:nvSpPr>
         <p:spPr>
@@ -2152,31 +2145,30 @@
           <a:noFill/>
         </p:spPr>
         <p:txBody>
-          <a:bodyPr wrap="square" rtlCol="0" anchor="ctr"/>
-          <a:lstStyle/>
-          <a:p>
-            <a:pPr marL="0" indent="0" algn="ctr">
-              <a:buNone/>
-            </a:pPr>
-            <a:r>
-              <a:rPr lang="en-US" sz="800" dirty="0">
+          <a:bodyPr wrap="square">
+            <a:spAutoFit/>
+          </a:bodyPr>
+          <a:lstStyle/>
+          <a:p>
+            <a:pPr algn="ctr">
+              <a:defRPr/>
+            </a:pPr>
+            <a:r>
+              <a:rPr sz="800">
                 <a:solidFill>
                   <a:srgbClr val="888888"/>
                 </a:solidFill>
-                <a:latin typeface="Arial" panose="020B0604020202020204" pitchFamily="34" charset="0"/>
-                <a:ea typeface="Arial" panose="020B0604020202020204" pitchFamily="34" charset="-122"/>
-                <a:cs typeface="Arial" panose="020B0604020202020204" pitchFamily="34" charset="-120"/>
+                <a:latin typeface="Arial"/>
               </a:rPr>
               <a:t>General - RPS Data</a:t>
             </a:r>
-            <a:endParaRPr lang="en-US" sz="800" dirty="0"/>
           </a:p>
         </p:txBody>
       </p:sp>
       <p:sp>
         <p:nvSpPr>
           <p:cNvPr id="4" name="Text 1"/>
-          <p:cNvSpPr/>
+          <p:cNvSpPr txBox="1"/>
           <p:nvPr/>
         </p:nvSpPr>
         <p:spPr>
@@ -2190,31 +2182,30 @@
           <a:noFill/>
         </p:spPr>
         <p:txBody>
-          <a:bodyPr wrap="square" rtlCol="0" anchor="ctr"/>
-          <a:lstStyle/>
-          <a:p>
-            <a:pPr marL="0" indent="0" algn="r">
-              <a:buNone/>
-            </a:pPr>
-            <a:r>
-              <a:rPr lang="en-US" sz="800" dirty="0">
+          <a:bodyPr wrap="square">
+            <a:spAutoFit/>
+          </a:bodyPr>
+          <a:lstStyle/>
+          <a:p>
+            <a:pPr algn="r">
+              <a:defRPr/>
+            </a:pPr>
+            <a:r>
+              <a:rPr sz="800">
                 <a:solidFill>
                   <a:srgbClr val="888888"/>
                 </a:solidFill>
-                <a:latin typeface="Arial" panose="020B0604020202020204" pitchFamily="34" charset="0"/>
-                <a:ea typeface="Arial" panose="020B0604020202020204" pitchFamily="34" charset="-122"/>
-                <a:cs typeface="Arial" panose="020B0604020202020204" pitchFamily="34" charset="-120"/>
+                <a:latin typeface="Arial"/>
               </a:rPr>
               <a:t>2026 - RPS Consulting all rights reserved    2</a:t>
             </a:r>
-            <a:endParaRPr lang="en-US" sz="800" dirty="0"/>
           </a:p>
         </p:txBody>
       </p:sp>
       <p:sp>
         <p:nvSpPr>
           <p:cNvPr id="5" name="Text 2"/>
-          <p:cNvSpPr/>
+          <p:cNvSpPr txBox="1"/>
           <p:nvPr/>
         </p:nvSpPr>
         <p:spPr>
@@ -2228,153 +2219,85 @@
           <a:noFill/>
         </p:spPr>
         <p:txBody>
-          <a:bodyPr wrap="square" lIns="0" tIns="0" rIns="0" bIns="0" rtlCol="0" anchor="ctr"/>
-          <a:lstStyle/>
-          <a:p>
-            <a:pPr marL="0" indent="0">
-              <a:buNone/>
-            </a:pPr>
-            <a:r>
-              <a:rPr lang="en-US" sz="2600" b="1" dirty="0">
+          <a:bodyPr wrap="square" lIns="0" rIns="0" tIns="0" bIns="0">
+            <a:spAutoFit/>
+          </a:bodyPr>
+          <a:lstStyle/>
+          <a:p>
+            <a:pPr>
+              <a:defRPr/>
+            </a:pPr>
+            <a:r>
+              <a:rPr sz="2600" b="1">
                 <a:solidFill>
                   <a:srgbClr val="0096CC"/>
                 </a:solidFill>
-                <a:latin typeface="Arial" panose="020B0604020202020204" pitchFamily="34" charset="0"/>
-                <a:ea typeface="Arial" panose="020B0604020202020204" pitchFamily="34" charset="-122"/>
-                <a:cs typeface="Arial" panose="020B0604020202020204" pitchFamily="34" charset="-120"/>
-              </a:rPr>
-              <a:t>System Modules &amp; Features</a:t>
-            </a:r>
-            <a:endParaRPr lang="en-US" sz="2600" dirty="0"/>
+                <a:latin typeface="Arial"/>
+              </a:rPr>
+              <a:t>Smart Parking Management System</a:t>
+            </a:r>
           </a:p>
         </p:txBody>
       </p:sp>
       <p:sp>
         <p:nvSpPr>
           <p:cNvPr id="6" name="Text 3"/>
-          <p:cNvSpPr/>
-          <p:nvPr/>
-        </p:nvSpPr>
-        <p:spPr>
-          <a:xfrm>
-            <a:off x="457200" y="824865"/>
-            <a:ext cx="8229600" cy="3160395"/>
-          </a:xfrm>
-          <a:prstGeom prst="rect">
-            <a:avLst/>
-          </a:prstGeom>
-          <a:noFill/>
-        </p:spPr>
-        <p:txBody>
-          <a:bodyPr wrap="square" rtlCol="0" anchor="ctr"/>
-          <a:lstStyle/>
-          <a:p>
-            <a:pPr marL="342900" indent="-342900" algn="just">
-              <a:spcAft>
-                <a:spcPts val="1000"/>
-              </a:spcAft>
-              <a:buSzPct val="100000"/>
-              <a:buChar char="•"/>
-            </a:pPr>
-            <a:r>
-              <a:rPr lang="en-US" sz="1400" dirty="0">
-                <a:solidFill>
-                  <a:srgbClr val="333333"/>
-                </a:solidFill>
-                <a:latin typeface="Arial" panose="020B0604020202020204" pitchFamily="34" charset="0"/>
-                <a:ea typeface="Arial" panose="020B0604020202020204" pitchFamily="34" charset="-122"/>
-                <a:cs typeface="Arial" panose="020B0604020202020204" pitchFamily="34" charset="-120"/>
-              </a:rPr>
-              <a:t>The Smart Parking Management System is structured around two primary user roles — Administrator and Customer — each with distinct capabilities and access levels.</a:t>
-            </a:r>
-            <a:endParaRPr lang="en-US" sz="1400" dirty="0"/>
-          </a:p>
-          <a:p>
-            <a:pPr marL="342900" indent="-342900" algn="just">
-              <a:spcAft>
-                <a:spcPts val="1000"/>
-              </a:spcAft>
-              <a:buSzPct val="100000"/>
-              <a:buChar char="•"/>
-            </a:pPr>
-            <a:r>
-              <a:rPr lang="en-US" sz="1400" dirty="0">
-                <a:solidFill>
-                  <a:srgbClr val="333333"/>
-                </a:solidFill>
-                <a:latin typeface="Arial" panose="020B0604020202020204" pitchFamily="34" charset="0"/>
-                <a:ea typeface="Arial" panose="020B0604020202020204" pitchFamily="34" charset="-122"/>
-                <a:cs typeface="Arial" panose="020B0604020202020204" pitchFamily="34" charset="-120"/>
-              </a:rPr>
-              <a:t>The Administrator oversees users, parking lots, parking slots, parking records, and revenue monitoring, ensuring full control and efficient maintenance of the infrastructure.</a:t>
-            </a:r>
-            <a:endParaRPr lang="en-US" sz="1400" dirty="0"/>
-          </a:p>
-          <a:p>
-            <a:pPr marL="342900" indent="-342900" algn="just">
-              <a:spcAft>
-                <a:spcPts val="1000"/>
-              </a:spcAft>
-              <a:buSzPct val="100000"/>
-              <a:buChar char="•"/>
-            </a:pPr>
-            <a:r>
-              <a:rPr lang="en-US" sz="1400" dirty="0">
-                <a:solidFill>
-                  <a:srgbClr val="333333"/>
-                </a:solidFill>
-                <a:latin typeface="Arial" panose="020B0604020202020204" pitchFamily="34" charset="0"/>
-                <a:ea typeface="Arial" panose="020B0604020202020204" pitchFamily="34" charset="-122"/>
-                <a:cs typeface="Arial" panose="020B0604020202020204" pitchFamily="34" charset="-120"/>
-              </a:rPr>
-              <a:t>The Customer interacts with the system by creating an account, logging in, registering vehicles, reserving parking slots, making payments, and downloading billing receipts.</a:t>
-            </a:r>
-            <a:endParaRPr lang="en-US" sz="1400" dirty="0"/>
-          </a:p>
-          <a:p>
-            <a:pPr marL="342900" indent="-342900" algn="just">
-              <a:spcAft>
-                <a:spcPts val="1000"/>
-              </a:spcAft>
-              <a:buSzPct val="100000"/>
-              <a:buChar char="•"/>
-            </a:pPr>
-            <a:r>
-              <a:rPr lang="en-US" sz="1400" dirty="0">
-                <a:solidFill>
-                  <a:srgbClr val="333333"/>
-                </a:solidFill>
-                <a:latin typeface="Arial" panose="020B0604020202020204" pitchFamily="34" charset="0"/>
-                <a:ea typeface="Arial" panose="020B0604020202020204" pitchFamily="34" charset="-122"/>
-                <a:cs typeface="Arial" panose="020B0604020202020204" pitchFamily="34" charset="-120"/>
-              </a:rPr>
-              <a:t>JWT-based authentication is embedded throughout the system to protect resources, enforce role-based access, and secure all sensitive user data.</a:t>
-            </a:r>
-            <a:endParaRPr lang="en-US" sz="1400" dirty="0"/>
-          </a:p>
-          <a:p>
-            <a:pPr marL="342900" indent="-342900" algn="just">
-              <a:spcAft>
-                <a:spcPts val="1000"/>
-              </a:spcAft>
-              <a:buSzPct val="100000"/>
-              <a:buChar char="•"/>
-            </a:pPr>
-            <a:r>
-              <a:rPr lang="en-US" sz="1400" dirty="0">
-                <a:solidFill>
-                  <a:srgbClr val="333333"/>
-                </a:solidFill>
-                <a:latin typeface="Arial" panose="020B0604020202020204" pitchFamily="34" charset="0"/>
-                <a:ea typeface="Arial" panose="020B0604020202020204" pitchFamily="34" charset="-122"/>
-                <a:cs typeface="Arial" panose="020B0604020202020204" pitchFamily="34" charset="-120"/>
-              </a:rPr>
-              <a:t>The application centralizes all parking operations — vehicle management, lot and slot handling, reservations, billing, and payments — into one cohesive platform, cutting manual effort and improving efficiency.</a:t>
-            </a:r>
-            <a:endParaRPr lang="en-US" sz="1400" dirty="0"/>
-          </a:p>
-        </p:txBody>
-      </p:sp>
+          <p:cNvSpPr txBox="1"/>
+          <p:nvPr/>
+        </p:nvSpPr>
+        <p:spPr>
+          <a:xfrm>
+            <a:off x="400685" y="823087"/>
+            <a:ext cx="8229600" cy="347472"/>
+          </a:xfrm>
+          <a:prstGeom prst="rect">
+            <a:avLst/>
+          </a:prstGeom>
+          <a:noFill/>
+        </p:spPr>
+        <p:txBody>
+          <a:bodyPr wrap="square" lIns="0" rIns="0" tIns="0" bIns="0">
+            <a:spAutoFit/>
+          </a:bodyPr>
+          <a:lstStyle/>
+          <a:p>
+            <a:pPr/>
+            <a:r>
+              <a:rPr sz="1800" b="1">
+                <a:solidFill>
+                  <a:srgbClr val="0096CC"/>
+                </a:solidFill>
+                <a:latin typeface="Arial"/>
+              </a:rPr>
+              <a:t>Entity Relationship Diagram</a:t>
+            </a:r>
+          </a:p>
+        </p:txBody>
+      </p:sp>
+      <p:pic>
+        <p:nvPicPr>
+          <p:cNvPr id="7" name="Picture 6" descr="ER_page_1.png"/>
+          <p:cNvPicPr>
+            <a:picLocks noChangeAspect="1"/>
+          </p:cNvPicPr>
+          <p:nvPr/>
+        </p:nvPicPr>
+        <p:blipFill>
+          <a:blip r:embed="rId3"/>
+          <a:stretch>
+            <a:fillRect/>
+          </a:stretch>
+        </p:blipFill>
+        <p:spPr>
+          <a:xfrm>
+            <a:off x="3504937" y="1403604"/>
+            <a:ext cx="2134124" cy="3017520"/>
+          </a:xfrm>
+          <a:prstGeom prst="rect">
+            <a:avLst/>
+          </a:prstGeom>
+        </p:spPr>
+      </p:pic>
     </p:spTree>
   </p:cSld>
   <p:clrMapOvr>
@@ -2540,7 +2463,7 @@
                 <a:ea typeface="Arial" panose="020B0604020202020204" pitchFamily="34" charset="-122"/>
                 <a:cs typeface="Arial" panose="020B0604020202020204" pitchFamily="34" charset="-120"/>
               </a:rPr>
-              <a:t>System Workflow</a:t>
+              <a:t>System Modules &amp; Features</a:t>
             </a:r>
             <a:endParaRPr lang="en-US" sz="2600" dirty="0"/>
           </a:p>
@@ -2554,8 +2477,8 @@
         </p:nvSpPr>
         <p:spPr>
           <a:xfrm>
-            <a:off x="379095" y="822960"/>
-            <a:ext cx="8229600" cy="3479165"/>
+            <a:off x="457200" y="824865"/>
+            <a:ext cx="8229600" cy="3160395"/>
           </a:xfrm>
           <a:prstGeom prst="rect">
             <a:avLst/>
@@ -2582,7 +2505,7 @@
                 <a:ea typeface="Arial" panose="020B0604020202020204" pitchFamily="34" charset="-122"/>
                 <a:cs typeface="Arial" panose="020B0604020202020204" pitchFamily="34" charset="-120"/>
               </a:rPr>
-              <a:t>The workflow begins with user authentication — upon successful login, a JWT token is issued and used to authorize all subsequent requests, ensuring secure communication across the application.</a:t>
+              <a:t>The Smart Parking Management System is structured around two primary user roles — Administrator and Customer — each with distinct capabilities and access levels.</a:t>
             </a:r>
             <a:endParaRPr lang="en-US" sz="1400" dirty="0"/>
           </a:p>
@@ -2603,7 +2526,7 @@
                 <a:ea typeface="Arial" panose="020B0604020202020204" pitchFamily="34" charset="-122"/>
                 <a:cs typeface="Arial" panose="020B0604020202020204" pitchFamily="34" charset="-120"/>
               </a:rPr>
-              <a:t>Customers register their vehicles and choose a parking lot based on current availability. The system instantly reflects available slots filtered by lot and vehicle type, and a reservation is created once the user confirms a slot.</a:t>
+              <a:t>The Administrator oversees users, parking lots, parking slots, parking records, and revenue monitoring, ensuring full control and efficient maintenance of the infrastructure.</a:t>
             </a:r>
             <a:endParaRPr lang="en-US" sz="1400" dirty="0"/>
           </a:p>
@@ -2624,7 +2547,7 @@
                 <a:ea typeface="Arial" panose="020B0604020202020204" pitchFamily="34" charset="-122"/>
                 <a:cs typeface="Arial" panose="020B0604020202020204" pitchFamily="34" charset="-120"/>
               </a:rPr>
-              <a:t>At vehicle entry, the system captures the entry timestamp and marks the selected slot as occupied. When the vehicle exits, the exit time is recorded, parking duration is computed, and the slot is released back to available status.</a:t>
+              <a:t>The Customer interacts with the system by creating an account, logging in, registering vehicles, reserving parking slots, making payments, and downloading billing receipts.</a:t>
             </a:r>
             <a:endParaRPr lang="en-US" sz="1400" dirty="0"/>
           </a:p>
@@ -2645,7 +2568,7 @@
                 <a:ea typeface="Arial" panose="020B0604020202020204" pitchFamily="34" charset="-122"/>
                 <a:cs typeface="Arial" panose="020B0604020202020204" pitchFamily="34" charset="-120"/>
               </a:rPr>
-              <a:t>The billing module automatically calculates charges based on the session duration and triggers payment processing. A receipt is made available for download upon successful payment.</a:t>
+              <a:t>JWT-based authentication is embedded throughout the system to protect resources, enforce role-based access, and secure all sensitive user data.</a:t>
             </a:r>
             <a:endParaRPr lang="en-US" sz="1400" dirty="0"/>
           </a:p>
@@ -2666,7 +2589,7 @@
                 <a:ea typeface="Arial" panose="020B0604020202020204" pitchFamily="34" charset="-122"/>
                 <a:cs typeface="Arial" panose="020B0604020202020204" pitchFamily="34" charset="-120"/>
               </a:rPr>
-              <a:t>All data flows through the following entities: User, Vehicle, Parking Lot, Parking Slot, Reservation, Parking Record, and Billing — ensuring complete traceability of every parking session.</a:t>
+              <a:t>The application centralizes all parking operations — vehicle management, lot and slot handling, reservations, billing, and payments — into one cohesive platform, cutting manual effort and improving efficiency.</a:t>
             </a:r>
             <a:endParaRPr lang="en-US" sz="1400" dirty="0"/>
           </a:p>
@@ -2813,8 +2736,8 @@
         </p:nvSpPr>
         <p:spPr>
           <a:xfrm>
-            <a:off x="457200" y="201168"/>
-            <a:ext cx="8229600" cy="411480"/>
+            <a:off x="457200" y="228600"/>
+            <a:ext cx="8229600" cy="438912"/>
           </a:xfrm>
           <a:prstGeom prst="rect">
             <a:avLst/>
@@ -2837,7 +2760,7 @@
                 <a:ea typeface="Arial" panose="020B0604020202020204" pitchFamily="34" charset="-122"/>
                 <a:cs typeface="Arial" panose="020B0604020202020204" pitchFamily="34" charset="-120"/>
               </a:rPr>
-              <a:t>DevOps, Deployment &amp; Benefits</a:t>
+              <a:t>System Workflow</a:t>
             </a:r>
             <a:endParaRPr lang="en-US" sz="2600" dirty="0"/>
           </a:p>
@@ -2851,8 +2774,8 @@
         </p:nvSpPr>
         <p:spPr>
           <a:xfrm>
-            <a:off x="457200" y="1022350"/>
-            <a:ext cx="8229600" cy="2011680"/>
+            <a:off x="379095" y="822960"/>
+            <a:ext cx="8229600" cy="3479165"/>
           </a:xfrm>
           <a:prstGeom prst="rect">
             <a:avLst/>
@@ -2865,13 +2788,13 @@
           <a:p>
             <a:pPr marL="342900" indent="-342900" algn="just">
               <a:spcAft>
-                <a:spcPts val="800"/>
+                <a:spcPts val="1000"/>
               </a:spcAft>
               <a:buSzPct val="100000"/>
               <a:buChar char="•"/>
             </a:pPr>
             <a:r>
-              <a:rPr lang="en-US" sz="1300" dirty="0">
+              <a:rPr lang="en-US" sz="1400" dirty="0">
                 <a:solidFill>
                   <a:srgbClr val="333333"/>
                 </a:solidFill>
@@ -2879,20 +2802,20 @@
                 <a:ea typeface="Arial" panose="020B0604020202020204" pitchFamily="34" charset="-122"/>
                 <a:cs typeface="Arial" panose="020B0604020202020204" pitchFamily="34" charset="-120"/>
               </a:rPr>
-              <a:t>The system is built with Thymeleaf for server-side rendering, Spring Boot for backend logic, and MySQL for persistent data storage. Spring Security with JWT handles access control; Swagger provides API documentation; and Spring Boot Actuator monitors application health and metrics.</a:t>
-            </a:r>
-            <a:endParaRPr lang="en-US" sz="1300" dirty="0"/>
+              <a:t>The workflow begins with user authentication — upon successful login, a JWT token is issued and used to authorize all subsequent requests, ensuring secure communication across the application.</a:t>
+            </a:r>
+            <a:endParaRPr lang="en-US" sz="1400" dirty="0"/>
           </a:p>
           <a:p>
             <a:pPr marL="342900" indent="-342900" algn="just">
               <a:spcAft>
-                <a:spcPts val="800"/>
+                <a:spcPts val="1000"/>
               </a:spcAft>
               <a:buSzPct val="100000"/>
               <a:buChar char="•"/>
             </a:pPr>
             <a:r>
-              <a:rPr lang="en-US" sz="1300" dirty="0">
+              <a:rPr lang="en-US" sz="1400" dirty="0">
                 <a:solidFill>
                   <a:srgbClr val="333333"/>
                 </a:solidFill>
@@ -2900,20 +2823,20 @@
                 <a:ea typeface="Arial" panose="020B0604020202020204" pitchFamily="34" charset="-122"/>
                 <a:cs typeface="Arial" panose="020B0604020202020204" pitchFamily="34" charset="-120"/>
               </a:rPr>
-              <a:t>For environment-agnostic deployment, the application is containerized using Docker. Kubernetes orchestrates the containers across nodes, delivering high availability and simplified rollout management.</a:t>
-            </a:r>
-            <a:endParaRPr lang="en-US" sz="1300" dirty="0"/>
+              <a:t>Customers register their vehicles and choose a parking lot based on current availability. The system instantly reflects available slots filtered by lot and vehicle type, and a reservation is created once the user confirms a slot.</a:t>
+            </a:r>
+            <a:endParaRPr lang="en-US" sz="1400" dirty="0"/>
           </a:p>
           <a:p>
             <a:pPr marL="342900" indent="-342900" algn="just">
               <a:spcAft>
-                <a:spcPts val="800"/>
+                <a:spcPts val="1000"/>
               </a:spcAft>
               <a:buSzPct val="100000"/>
               <a:buChar char="•"/>
             </a:pPr>
             <a:r>
-              <a:rPr lang="en-US" sz="1300" dirty="0">
+              <a:rPr lang="en-US" sz="1400" dirty="0">
                 <a:solidFill>
                   <a:srgbClr val="333333"/>
                 </a:solidFill>
@@ -2921,9 +2844,51 @@
                 <a:ea typeface="Arial" panose="020B0604020202020204" pitchFamily="34" charset="-122"/>
                 <a:cs typeface="Arial" panose="020B0604020202020204" pitchFamily="34" charset="-120"/>
               </a:rPr>
-              <a:t>A Jenkins CI/CD pipeline automates the entire delivery lifecycle — from source code checkout and application build to testing, Docker image creation, and Kubernetes deployment — ensuring fast and reliable releases.</a:t>
-            </a:r>
-            <a:endParaRPr lang="en-US" sz="1300" dirty="0"/>
+              <a:t>At vehicle entry, the system captures the entry timestamp and marks the selected slot as occupied. When the vehicle exits, the exit time is recorded, parking duration is computed, and the slot is released back to available status.</a:t>
+            </a:r>
+            <a:endParaRPr lang="en-US" sz="1400" dirty="0"/>
+          </a:p>
+          <a:p>
+            <a:pPr marL="342900" indent="-342900" algn="just">
+              <a:spcAft>
+                <a:spcPts val="1000"/>
+              </a:spcAft>
+              <a:buSzPct val="100000"/>
+              <a:buChar char="•"/>
+            </a:pPr>
+            <a:r>
+              <a:rPr lang="en-US" sz="1400" dirty="0">
+                <a:solidFill>
+                  <a:srgbClr val="333333"/>
+                </a:solidFill>
+                <a:latin typeface="Arial" panose="020B0604020202020204" pitchFamily="34" charset="0"/>
+                <a:ea typeface="Arial" panose="020B0604020202020204" pitchFamily="34" charset="-122"/>
+                <a:cs typeface="Arial" panose="020B0604020202020204" pitchFamily="34" charset="-120"/>
+              </a:rPr>
+              <a:t>The billing module automatically calculates charges based on the session duration and triggers payment processing. A receipt is made available for download upon successful payment.</a:t>
+            </a:r>
+            <a:endParaRPr lang="en-US" sz="1400" dirty="0"/>
+          </a:p>
+          <a:p>
+            <a:pPr marL="342900" indent="-342900" algn="just">
+              <a:spcAft>
+                <a:spcPts val="1000"/>
+              </a:spcAft>
+              <a:buSzPct val="100000"/>
+              <a:buChar char="•"/>
+            </a:pPr>
+            <a:r>
+              <a:rPr lang="en-US" sz="1400" dirty="0">
+                <a:solidFill>
+                  <a:srgbClr val="333333"/>
+                </a:solidFill>
+                <a:latin typeface="Arial" panose="020B0604020202020204" pitchFamily="34" charset="0"/>
+                <a:ea typeface="Arial" panose="020B0604020202020204" pitchFamily="34" charset="-122"/>
+                <a:cs typeface="Arial" panose="020B0604020202020204" pitchFamily="34" charset="-120"/>
+              </a:rPr>
+              <a:t>All data flows through the following entities: User, Vehicle, Parking Lot, Parking Slot, Reservation, Parking Record, and Billing — ensuring complete traceability of every parking session.</a:t>
+            </a:r>
+            <a:endParaRPr lang="en-US" sz="1400" dirty="0"/>
           </a:p>
         </p:txBody>
       </p:sp>
@@ -2952,10 +2917,17 @@
         <p:cNvGrpSpPr/>
         <p:nvPr/>
       </p:nvGrpSpPr>
-      <p:grpSpPr/>
+      <p:grpSpPr>
+        <a:xfrm>
+          <a:off x="0" y="0"/>
+          <a:ext cx="0" cy="0"/>
+          <a:chOff x="0" y="0"/>
+          <a:chExt cx="0" cy="0"/>
+        </a:xfrm>
+      </p:grpSpPr>
       <p:pic>
         <p:nvPicPr>
-          <p:cNvPr id="2" name="Picture 1" descr="image.png"/>
+          <p:cNvPr id="2" name="Image 0" descr="preencoded.png"/>
           <p:cNvPicPr>
             <a:picLocks noChangeAspect="1"/>
           </p:cNvPicPr>
@@ -2980,7 +2952,7 @@
       <p:sp>
         <p:nvSpPr>
           <p:cNvPr id="3" name="Text 0"/>
-          <p:cNvSpPr txBox="1"/>
+          <p:cNvSpPr/>
           <p:nvPr/>
         </p:nvSpPr>
         <p:spPr>
@@ -2994,36 +2966,31 @@
           <a:noFill/>
         </p:spPr>
         <p:txBody>
-          <a:bodyPr wrap="square">
-            <a:spAutoFit/>
-          </a:bodyPr>
-          <a:lstStyle/>
-          <a:p>
-            <a:pPr algn="ctr">
-              <a:defRPr/>
-            </a:pPr>
-            <a:r>
-              <a:rPr sz="800">
+          <a:bodyPr wrap="square" rtlCol="0" anchor="ctr"/>
+          <a:lstStyle/>
+          <a:p>
+            <a:pPr marL="0" indent="0" algn="ctr">
+              <a:buNone/>
+            </a:pPr>
+            <a:r>
+              <a:rPr lang="en-US" sz="800" dirty="0">
                 <a:solidFill>
                   <a:srgbClr val="888888"/>
                 </a:solidFill>
-                <a:latin typeface="Arial" panose="020B0604020202020204"/>
+                <a:latin typeface="Arial" panose="020B0604020202020204" pitchFamily="34" charset="0"/>
+                <a:ea typeface="Arial" panose="020B0604020202020204" pitchFamily="34" charset="-122"/>
+                <a:cs typeface="Arial" panose="020B0604020202020204" pitchFamily="34" charset="-120"/>
               </a:rPr>
               <a:t>General - RPS Data</a:t>
             </a:r>
-            <a:endParaRPr sz="800">
-              <a:solidFill>
-                <a:srgbClr val="888888"/>
-              </a:solidFill>
-              <a:latin typeface="Arial" panose="020B0604020202020204"/>
-            </a:endParaRPr>
+            <a:endParaRPr lang="en-US" sz="800" dirty="0"/>
           </a:p>
         </p:txBody>
       </p:sp>
       <p:sp>
         <p:nvSpPr>
           <p:cNvPr id="4" name="Text 1"/>
-          <p:cNvSpPr txBox="1"/>
+          <p:cNvSpPr/>
           <p:nvPr/>
         </p:nvSpPr>
         <p:spPr>
@@ -3037,139 +3004,149 @@
           <a:noFill/>
         </p:spPr>
         <p:txBody>
-          <a:bodyPr wrap="square">
-            <a:spAutoFit/>
-          </a:bodyPr>
-          <a:lstStyle/>
-          <a:p>
-            <a:pPr algn="r">
-              <a:defRPr/>
-            </a:pPr>
-            <a:r>
-              <a:rPr sz="800">
+          <a:bodyPr wrap="square" rtlCol="0" anchor="ctr"/>
+          <a:lstStyle/>
+          <a:p>
+            <a:pPr marL="0" indent="0" algn="r">
+              <a:buNone/>
+            </a:pPr>
+            <a:r>
+              <a:rPr lang="en-US" sz="800" dirty="0">
                 <a:solidFill>
                   <a:srgbClr val="888888"/>
                 </a:solidFill>
-                <a:latin typeface="Arial" panose="020B0604020202020204"/>
+                <a:latin typeface="Arial" panose="020B0604020202020204" pitchFamily="34" charset="0"/>
+                <a:ea typeface="Arial" panose="020B0604020202020204" pitchFamily="34" charset="-122"/>
+                <a:cs typeface="Arial" panose="020B0604020202020204" pitchFamily="34" charset="-120"/>
               </a:rPr>
               <a:t>2026 - RPS Consulting all rights reserved    2</a:t>
             </a:r>
-            <a:endParaRPr sz="800">
-              <a:solidFill>
-                <a:srgbClr val="888888"/>
-              </a:solidFill>
-              <a:latin typeface="Arial" panose="020B0604020202020204"/>
-            </a:endParaRPr>
+            <a:endParaRPr lang="en-US" sz="800" dirty="0"/>
           </a:p>
         </p:txBody>
       </p:sp>
       <p:sp>
         <p:nvSpPr>
           <p:cNvPr id="5" name="Text 2"/>
-          <p:cNvSpPr txBox="1"/>
-          <p:nvPr/>
-        </p:nvSpPr>
-        <p:spPr>
-          <a:xfrm>
-            <a:off x="457200" y="228600"/>
-            <a:ext cx="8229600" cy="438912"/>
-          </a:xfrm>
-          <a:prstGeom prst="rect">
-            <a:avLst/>
-          </a:prstGeom>
-          <a:noFill/>
-        </p:spPr>
-        <p:txBody>
-          <a:bodyPr wrap="square" lIns="0" tIns="0" rIns="0" bIns="0">
-            <a:spAutoFit/>
-          </a:bodyPr>
-          <a:lstStyle/>
-          <a:p>
-            <a:pPr>
-              <a:defRPr/>
-            </a:pPr>
-            <a:r>
-              <a:rPr sz="2600" b="1">
+          <p:cNvSpPr/>
+          <p:nvPr/>
+        </p:nvSpPr>
+        <p:spPr>
+          <a:xfrm>
+            <a:off x="457200" y="201168"/>
+            <a:ext cx="8229600" cy="411480"/>
+          </a:xfrm>
+          <a:prstGeom prst="rect">
+            <a:avLst/>
+          </a:prstGeom>
+          <a:noFill/>
+        </p:spPr>
+        <p:txBody>
+          <a:bodyPr wrap="square" lIns="0" tIns="0" rIns="0" bIns="0" rtlCol="0" anchor="ctr"/>
+          <a:lstStyle/>
+          <a:p>
+            <a:pPr marL="0" indent="0">
+              <a:buNone/>
+            </a:pPr>
+            <a:r>
+              <a:rPr lang="en-US" sz="2600" b="1" dirty="0">
                 <a:solidFill>
                   <a:srgbClr val="0096CC"/>
                 </a:solidFill>
-                <a:latin typeface="Arial" panose="020B0604020202020204"/>
-              </a:rPr>
-              <a:t>Smart Parking Management System</a:t>
-            </a:r>
-            <a:endParaRPr sz="2600" b="1">
-              <a:solidFill>
-                <a:srgbClr val="0096CC"/>
-              </a:solidFill>
-              <a:latin typeface="Arial" panose="020B0604020202020204"/>
-            </a:endParaRPr>
+                <a:latin typeface="Arial" panose="020B0604020202020204" pitchFamily="34" charset="0"/>
+                <a:ea typeface="Arial" panose="020B0604020202020204" pitchFamily="34" charset="-122"/>
+                <a:cs typeface="Arial" panose="020B0604020202020204" pitchFamily="34" charset="-120"/>
+              </a:rPr>
+              <a:t>DevOps, Deployment &amp; Benefits</a:t>
+            </a:r>
+            <a:endParaRPr lang="en-US" sz="2600" dirty="0"/>
           </a:p>
         </p:txBody>
       </p:sp>
       <p:sp>
         <p:nvSpPr>
           <p:cNvPr id="6" name="Text 3"/>
-          <p:cNvSpPr txBox="1"/>
-          <p:nvPr/>
-        </p:nvSpPr>
-        <p:spPr>
-          <a:xfrm>
-            <a:off x="400685" y="823087"/>
-            <a:ext cx="8229600" cy="347472"/>
-          </a:xfrm>
-          <a:prstGeom prst="rect">
-            <a:avLst/>
-          </a:prstGeom>
-          <a:noFill/>
-        </p:spPr>
-        <p:txBody>
-          <a:bodyPr wrap="square" lIns="0" tIns="0" rIns="0" bIns="0">
-            <a:spAutoFit/>
-          </a:bodyPr>
-          <a:lstStyle/>
-          <a:p>
-            <a:r>
-              <a:rPr sz="1800" b="1">
-                <a:solidFill>
-                  <a:srgbClr val="0096CC"/>
-                </a:solidFill>
-                <a:latin typeface="Arial" panose="020B0604020202020204"/>
-              </a:rPr>
-              <a:t>Swagger REST API Documentation</a:t>
-            </a:r>
-            <a:endParaRPr sz="1800" b="1">
-              <a:solidFill>
-                <a:srgbClr val="0096CC"/>
-              </a:solidFill>
-              <a:latin typeface="Arial" panose="020B0604020202020204"/>
-            </a:endParaRPr>
-          </a:p>
-        </p:txBody>
-      </p:sp>
-      <p:pic>
-        <p:nvPicPr>
-          <p:cNvPr id="7" name="Picture 6" descr="Swagger.PNG"/>
-          <p:cNvPicPr>
-            <a:picLocks noChangeAspect="1"/>
-          </p:cNvPicPr>
-          <p:nvPr/>
-        </p:nvPicPr>
-        <p:blipFill>
-          <a:blip r:embed="rId2"/>
-          <a:stretch>
-            <a:fillRect/>
-          </a:stretch>
-        </p:blipFill>
-        <p:spPr>
-          <a:xfrm>
-            <a:off x="1724215" y="1403604"/>
-            <a:ext cx="5695569" cy="3017520"/>
-          </a:xfrm>
-          <a:prstGeom prst="rect">
-            <a:avLst/>
-          </a:prstGeom>
-        </p:spPr>
-      </p:pic>
+          <p:cNvSpPr/>
+          <p:nvPr/>
+        </p:nvSpPr>
+        <p:spPr>
+          <a:xfrm>
+            <a:off x="457200" y="1022350"/>
+            <a:ext cx="8229600" cy="2011680"/>
+          </a:xfrm>
+          <a:prstGeom prst="rect">
+            <a:avLst/>
+          </a:prstGeom>
+          <a:noFill/>
+        </p:spPr>
+        <p:txBody>
+          <a:bodyPr wrap="square" rtlCol="0" anchor="ctr"/>
+          <a:lstStyle/>
+          <a:p>
+            <a:pPr marL="342900" indent="-342900" algn="just">
+              <a:spcAft>
+                <a:spcPts val="800"/>
+              </a:spcAft>
+              <a:buSzPct val="100000"/>
+              <a:buChar char="•"/>
+            </a:pPr>
+            <a:r>
+              <a:rPr lang="en-US" sz="1300" dirty="0">
+                <a:solidFill>
+                  <a:srgbClr val="333333"/>
+                </a:solidFill>
+                <a:latin typeface="Arial" panose="020B0604020202020204" pitchFamily="34" charset="0"/>
+                <a:ea typeface="Arial" panose="020B0604020202020204" pitchFamily="34" charset="-122"/>
+                <a:cs typeface="Arial" panose="020B0604020202020204" pitchFamily="34" charset="-120"/>
+              </a:rPr>
+              <a:t>The system is built with Thymeleaf for server-side rendering, Spring Boot for backend logic, and MySQL for persistent data storage. Spring Security with JWT handles access control; Swagger provides API documentation; and Spring Boot Actuator monitors application health and metrics.</a:t>
+            </a:r>
+            <a:endParaRPr lang="en-US" sz="1300" dirty="0"/>
+          </a:p>
+          <a:p>
+            <a:pPr marL="342900" indent="-342900" algn="just">
+              <a:spcAft>
+                <a:spcPts val="800"/>
+              </a:spcAft>
+              <a:buSzPct val="100000"/>
+              <a:buChar char="•"/>
+            </a:pPr>
+            <a:r>
+              <a:rPr lang="en-US" sz="1300" dirty="0">
+                <a:solidFill>
+                  <a:srgbClr val="333333"/>
+                </a:solidFill>
+                <a:latin typeface="Arial" panose="020B0604020202020204" pitchFamily="34" charset="0"/>
+                <a:ea typeface="Arial" panose="020B0604020202020204" pitchFamily="34" charset="-122"/>
+                <a:cs typeface="Arial" panose="020B0604020202020204" pitchFamily="34" charset="-120"/>
+              </a:rPr>
+              <a:t>For environment-agnostic deployment, the application is containerized using Docker. Kubernetes orchestrates the containers across nodes, delivering high availability and simplified rollout management.</a:t>
+            </a:r>
+            <a:endParaRPr lang="en-US" sz="1300" dirty="0"/>
+          </a:p>
+          <a:p>
+            <a:pPr marL="342900" indent="-342900" algn="just">
+              <a:spcAft>
+                <a:spcPts val="800"/>
+              </a:spcAft>
+              <a:buSzPct val="100000"/>
+              <a:buChar char="•"/>
+            </a:pPr>
+            <a:r>
+              <a:rPr lang="en-US" sz="1300" dirty="0">
+                <a:solidFill>
+                  <a:srgbClr val="333333"/>
+                </a:solidFill>
+                <a:latin typeface="Arial" panose="020B0604020202020204" pitchFamily="34" charset="0"/>
+                <a:ea typeface="Arial" panose="020B0604020202020204" pitchFamily="34" charset="-122"/>
+                <a:cs typeface="Arial" panose="020B0604020202020204" pitchFamily="34" charset="-120"/>
+              </a:rPr>
+              <a:t>A Jenkins CI/CD pipeline automates the entire delivery lifecycle — from source code checkout and application build to testing, Docker image creation, and Kubernetes deployment — ensuring fast and reliable releases.</a:t>
+            </a:r>
+            <a:endParaRPr lang="en-US" sz="1300" dirty="0"/>
+          </a:p>
+        </p:txBody>
+      </p:sp>
     </p:spTree>
   </p:cSld>
   <p:clrMapOvr>
@@ -3378,7 +3355,7 @@
                 </a:solidFill>
                 <a:latin typeface="Arial" panose="020B0604020202020204"/>
               </a:rPr>
-              <a:t>Spring Boot Actuator Health Monitoring</a:t>
+              <a:t>Swagger REST API Documentation</a:t>
             </a:r>
             <a:endParaRPr sz="1800" b="1">
               <a:solidFill>
@@ -3391,7 +3368,7 @@
       </p:sp>
       <p:pic>
         <p:nvPicPr>
-          <p:cNvPr id="7" name="Picture 6" descr="actuator.PNG"/>
+          <p:cNvPr id="7" name="Picture 6" descr="Swagger.PNG"/>
           <p:cNvPicPr>
             <a:picLocks noChangeAspect="1"/>
           </p:cNvPicPr>
@@ -3405,8 +3382,8 @@
         </p:blipFill>
         <p:spPr>
           <a:xfrm>
-            <a:off x="1905301" y="1403604"/>
-            <a:ext cx="5333397" cy="3017520"/>
+            <a:off x="1724215" y="1403604"/>
+            <a:ext cx="5695569" cy="3017520"/>
           </a:xfrm>
           <a:prstGeom prst="rect">
             <a:avLst/>
@@ -3621,7 +3598,7 @@
                 </a:solidFill>
                 <a:latin typeface="Arial" panose="020B0604020202020204"/>
               </a:rPr>
-              <a:t>Postman API Verification Testing</a:t>
+              <a:t>Spring Boot Actuator Health Monitoring</a:t>
             </a:r>
             <a:endParaRPr sz="1800" b="1">
               <a:solidFill>
@@ -3634,7 +3611,7 @@
       </p:sp>
       <p:pic>
         <p:nvPicPr>
-          <p:cNvPr id="7" name="Picture 6" descr="postman.PNG"/>
+          <p:cNvPr id="7" name="Picture 6" descr="actuator.PNG"/>
           <p:cNvPicPr>
             <a:picLocks noChangeAspect="1"/>
           </p:cNvPicPr>
@@ -3648,8 +3625,8 @@
         </p:blipFill>
         <p:spPr>
           <a:xfrm>
-            <a:off x="1569988" y="1403604"/>
-            <a:ext cx="6004022" cy="3017520"/>
+            <a:off x="1905301" y="1403604"/>
+            <a:ext cx="5333397" cy="3017520"/>
           </a:xfrm>
           <a:prstGeom prst="rect">
             <a:avLst/>
@@ -3864,7 +3841,7 @@
                 </a:solidFill>
                 <a:latin typeface="Arial" panose="020B0604020202020204"/>
               </a:rPr>
-              <a:t>Docker Containers Deployment</a:t>
+              <a:t>Postman API Verification Testing</a:t>
             </a:r>
             <a:endParaRPr sz="1800" b="1">
               <a:solidFill>
@@ -3877,7 +3854,7 @@
       </p:sp>
       <p:pic>
         <p:nvPicPr>
-          <p:cNvPr id="7" name="Picture 6" descr="docker.PNG"/>
+          <p:cNvPr id="7" name="Picture 6" descr="postman.PNG"/>
           <p:cNvPicPr>
             <a:picLocks noChangeAspect="1"/>
           </p:cNvPicPr>
@@ -3891,8 +3868,8 @@
         </p:blipFill>
         <p:spPr>
           <a:xfrm>
-            <a:off x="1828603" y="1403604"/>
-            <a:ext cx="5486792" cy="3017520"/>
+            <a:off x="1569988" y="1403604"/>
+            <a:ext cx="6004022" cy="3017520"/>
           </a:xfrm>
           <a:prstGeom prst="rect">
             <a:avLst/>
@@ -4107,7 +4084,7 @@
                 </a:solidFill>
                 <a:latin typeface="Arial" panose="020B0604020202020204"/>
               </a:rPr>
-              <a:t>Docker Container Images</a:t>
+              <a:t>Docker Containers Deployment</a:t>
             </a:r>
             <a:endParaRPr sz="1800" b="1">
               <a:solidFill>
@@ -4120,7 +4097,7 @@
       </p:sp>
       <p:pic>
         <p:nvPicPr>
-          <p:cNvPr id="7" name="Picture 6" descr="docker-images.PNG"/>
+          <p:cNvPr id="7" name="Picture 6" descr="docker.PNG"/>
           <p:cNvPicPr>
             <a:picLocks noChangeAspect="1"/>
           </p:cNvPicPr>
@@ -4134,8 +4111,8 @@
         </p:blipFill>
         <p:spPr>
           <a:xfrm>
-            <a:off x="1827851" y="1403604"/>
-            <a:ext cx="5488297" cy="3017520"/>
+            <a:off x="1828603" y="1403604"/>
+            <a:ext cx="5486792" cy="3017520"/>
           </a:xfrm>
           <a:prstGeom prst="rect">
             <a:avLst/>
@@ -4350,7 +4327,7 @@
                 </a:solidFill>
                 <a:latin typeface="Arial" panose="020B0604020202020204"/>
               </a:rPr>
-              <a:t>Kubernetes MySQL Database Service</a:t>
+              <a:t>Docker Container Images</a:t>
             </a:r>
             <a:endParaRPr sz="1800" b="1">
               <a:solidFill>
@@ -4363,7 +4340,7 @@
       </p:sp>
       <p:pic>
         <p:nvPicPr>
-          <p:cNvPr id="7" name="Picture 6" descr="K8-sql.PNG"/>
+          <p:cNvPr id="7" name="Picture 6" descr="docker-images.PNG"/>
           <p:cNvPicPr>
             <a:picLocks noChangeAspect="1"/>
           </p:cNvPicPr>
@@ -4377,8 +4354,8 @@
         </p:blipFill>
         <p:spPr>
           <a:xfrm>
-            <a:off x="1798544" y="1403604"/>
-            <a:ext cx="5546911" cy="3017520"/>
+            <a:off x="1827851" y="1403604"/>
+            <a:ext cx="5488297" cy="3017520"/>
           </a:xfrm>
           <a:prstGeom prst="rect">
             <a:avLst/>
@@ -4593,7 +4570,7 @@
                 </a:solidFill>
                 <a:latin typeface="Arial" panose="020B0604020202020204"/>
               </a:rPr>
-              <a:t>Kubernetes Web UI Deployment</a:t>
+              <a:t>Kubernetes MySQL Database Service</a:t>
             </a:r>
             <a:endParaRPr sz="1800" b="1">
               <a:solidFill>
@@ -4606,7 +4583,7 @@
       </p:sp>
       <p:pic>
         <p:nvPicPr>
-          <p:cNvPr id="7" name="Picture 6" descr="k8-ui.PNG"/>
+          <p:cNvPr id="7" name="Picture 6" descr="K8-sql.PNG"/>
           <p:cNvPicPr>
             <a:picLocks noChangeAspect="1"/>
           </p:cNvPicPr>
@@ -4620,8 +4597,8 @@
         </p:blipFill>
         <p:spPr>
           <a:xfrm>
-            <a:off x="2175856" y="1403604"/>
-            <a:ext cx="4792287" cy="3017520"/>
+            <a:off x="1798544" y="1403604"/>
+            <a:ext cx="5546911" cy="3017520"/>
           </a:xfrm>
           <a:prstGeom prst="rect">
             <a:avLst/>
@@ -5159,7 +5136,7 @@
                 </a:solidFill>
                 <a:latin typeface="Arial" panose="020B0604020202020204"/>
               </a:rPr>
-              <a:t>Jenkins CI/CD Build Pipeline</a:t>
+              <a:t>Kubernetes Web UI Deployment</a:t>
             </a:r>
             <a:endParaRPr sz="1800" b="1">
               <a:solidFill>
@@ -5172,7 +5149,7 @@
       </p:sp>
       <p:pic>
         <p:nvPicPr>
-          <p:cNvPr id="7" name="Picture 6" descr="Jenkins.PNG"/>
+          <p:cNvPr id="7" name="Picture 6" descr="k8-ui.PNG"/>
           <p:cNvPicPr>
             <a:picLocks noChangeAspect="1"/>
           </p:cNvPicPr>
@@ -5186,8 +5163,8 @@
         </p:blipFill>
         <p:spPr>
           <a:xfrm>
-            <a:off x="1699215" y="1403604"/>
-            <a:ext cx="5745568" cy="3017520"/>
+            <a:off x="2175856" y="1403604"/>
+            <a:ext cx="4792287" cy="3017520"/>
           </a:xfrm>
           <a:prstGeom prst="rect">
             <a:avLst/>
@@ -5219,17 +5196,10 @@
         <p:cNvGrpSpPr/>
         <p:nvPr/>
       </p:nvGrpSpPr>
-      <p:grpSpPr>
-        <a:xfrm>
-          <a:off x="0" y="0"/>
-          <a:ext cx="0" cy="0"/>
-          <a:chOff x="0" y="0"/>
-          <a:chExt cx="0" cy="0"/>
-        </a:xfrm>
-      </p:grpSpPr>
+      <p:grpSpPr/>
       <p:pic>
         <p:nvPicPr>
-          <p:cNvPr id="2" name="Image 0" descr="preencoded.png"/>
+          <p:cNvPr id="2" name="Picture 1" descr="image.png"/>
           <p:cNvPicPr>
             <a:picLocks noChangeAspect="1"/>
           </p:cNvPicPr>
@@ -5254,7 +5224,7 @@
       <p:sp>
         <p:nvSpPr>
           <p:cNvPr id="3" name="Text 0"/>
-          <p:cNvSpPr/>
+          <p:cNvSpPr txBox="1"/>
           <p:nvPr/>
         </p:nvSpPr>
         <p:spPr>
@@ -5268,31 +5238,36 @@
           <a:noFill/>
         </p:spPr>
         <p:txBody>
-          <a:bodyPr wrap="square" rtlCol="0" anchor="ctr"/>
-          <a:lstStyle/>
-          <a:p>
-            <a:pPr marL="0" indent="0" algn="ctr">
-              <a:buNone/>
-            </a:pPr>
-            <a:r>
-              <a:rPr lang="en-US" sz="800" dirty="0">
+          <a:bodyPr wrap="square">
+            <a:spAutoFit/>
+          </a:bodyPr>
+          <a:lstStyle/>
+          <a:p>
+            <a:pPr algn="ctr">
+              <a:defRPr/>
+            </a:pPr>
+            <a:r>
+              <a:rPr sz="800">
                 <a:solidFill>
                   <a:srgbClr val="888888"/>
                 </a:solidFill>
-                <a:latin typeface="Arial" panose="020B0604020202020204" pitchFamily="34" charset="0"/>
-                <a:ea typeface="Arial" panose="020B0604020202020204" pitchFamily="34" charset="-122"/>
-                <a:cs typeface="Arial" panose="020B0604020202020204" pitchFamily="34" charset="-120"/>
+                <a:latin typeface="Arial" panose="020B0604020202020204"/>
               </a:rPr>
               <a:t>General - RPS Data</a:t>
             </a:r>
-            <a:endParaRPr lang="en-US" sz="800" dirty="0"/>
+            <a:endParaRPr sz="800">
+              <a:solidFill>
+                <a:srgbClr val="888888"/>
+              </a:solidFill>
+              <a:latin typeface="Arial" panose="020B0604020202020204"/>
+            </a:endParaRPr>
           </a:p>
         </p:txBody>
       </p:sp>
       <p:sp>
         <p:nvSpPr>
           <p:cNvPr id="4" name="Text 1"/>
-          <p:cNvSpPr/>
+          <p:cNvSpPr txBox="1"/>
           <p:nvPr/>
         </p:nvSpPr>
         <p:spPr>
@@ -5306,387 +5281,139 @@
           <a:noFill/>
         </p:spPr>
         <p:txBody>
-          <a:bodyPr wrap="square" rtlCol="0" anchor="ctr"/>
-          <a:lstStyle/>
-          <a:p>
-            <a:pPr marL="0" indent="0" algn="r">
-              <a:buNone/>
-            </a:pPr>
-            <a:r>
-              <a:rPr lang="en-US" sz="800" dirty="0">
+          <a:bodyPr wrap="square">
+            <a:spAutoFit/>
+          </a:bodyPr>
+          <a:lstStyle/>
+          <a:p>
+            <a:pPr algn="r">
+              <a:defRPr/>
+            </a:pPr>
+            <a:r>
+              <a:rPr sz="800">
                 <a:solidFill>
                   <a:srgbClr val="888888"/>
                 </a:solidFill>
-                <a:latin typeface="Arial" panose="020B0604020202020204" pitchFamily="34" charset="0"/>
-                <a:ea typeface="Arial" panose="020B0604020202020204" pitchFamily="34" charset="-122"/>
-                <a:cs typeface="Arial" panose="020B0604020202020204" pitchFamily="34" charset="-120"/>
+                <a:latin typeface="Arial" panose="020B0604020202020204"/>
               </a:rPr>
               <a:t>2026 - RPS Consulting all rights reserved    2</a:t>
             </a:r>
-            <a:endParaRPr lang="en-US" sz="800" dirty="0"/>
+            <a:endParaRPr sz="800">
+              <a:solidFill>
+                <a:srgbClr val="888888"/>
+              </a:solidFill>
+              <a:latin typeface="Arial" panose="020B0604020202020204"/>
+            </a:endParaRPr>
           </a:p>
         </p:txBody>
       </p:sp>
       <p:sp>
         <p:nvSpPr>
           <p:cNvPr id="5" name="Text 2"/>
-          <p:cNvSpPr/>
-          <p:nvPr/>
-        </p:nvSpPr>
-        <p:spPr>
-          <a:xfrm>
-            <a:off x="457200" y="201168"/>
-            <a:ext cx="8229600" cy="384048"/>
-          </a:xfrm>
-          <a:prstGeom prst="rect">
-            <a:avLst/>
-          </a:prstGeom>
-          <a:noFill/>
-        </p:spPr>
-        <p:txBody>
-          <a:bodyPr wrap="square" lIns="0" tIns="0" rIns="0" bIns="0" rtlCol="0" anchor="ctr"/>
-          <a:lstStyle/>
-          <a:p>
-            <a:pPr marL="0" indent="0">
-              <a:buNone/>
-            </a:pPr>
-            <a:r>
-              <a:rPr lang="en-US" sz="2200" b="1" dirty="0">
+          <p:cNvSpPr txBox="1"/>
+          <p:nvPr/>
+        </p:nvSpPr>
+        <p:spPr>
+          <a:xfrm>
+            <a:off x="457200" y="228600"/>
+            <a:ext cx="8229600" cy="438912"/>
+          </a:xfrm>
+          <a:prstGeom prst="rect">
+            <a:avLst/>
+          </a:prstGeom>
+          <a:noFill/>
+        </p:spPr>
+        <p:txBody>
+          <a:bodyPr wrap="square" lIns="0" tIns="0" rIns="0" bIns="0">
+            <a:spAutoFit/>
+          </a:bodyPr>
+          <a:lstStyle/>
+          <a:p>
+            <a:pPr>
+              <a:defRPr/>
+            </a:pPr>
+            <a:r>
+              <a:rPr sz="2600" b="1">
                 <a:solidFill>
                   <a:srgbClr val="0096CC"/>
                 </a:solidFill>
-                <a:latin typeface="Arial" panose="020B0604020202020204" pitchFamily="34" charset="0"/>
-                <a:ea typeface="Arial" panose="020B0604020202020204" pitchFamily="34" charset="-122"/>
-                <a:cs typeface="Arial" panose="020B0604020202020204" pitchFamily="34" charset="-120"/>
-              </a:rPr>
-              <a:t>Benefits:</a:t>
-            </a:r>
-            <a:endParaRPr lang="en-US" sz="2200" dirty="0"/>
+                <a:latin typeface="Arial" panose="020B0604020202020204"/>
+              </a:rPr>
+              <a:t>Smart Parking Management System</a:t>
+            </a:r>
+            <a:endParaRPr sz="2600" b="1">
+              <a:solidFill>
+                <a:srgbClr val="0096CC"/>
+              </a:solidFill>
+              <a:latin typeface="Arial" panose="020B0604020202020204"/>
+            </a:endParaRPr>
           </a:p>
         </p:txBody>
       </p:sp>
       <p:sp>
         <p:nvSpPr>
           <p:cNvPr id="6" name="Text 3"/>
-          <p:cNvSpPr/>
-          <p:nvPr/>
-        </p:nvSpPr>
-        <p:spPr>
-          <a:xfrm>
-            <a:off x="457200" y="682625"/>
-            <a:ext cx="8229600" cy="2080260"/>
-          </a:xfrm>
-          <a:prstGeom prst="rect">
-            <a:avLst/>
-          </a:prstGeom>
-          <a:noFill/>
-        </p:spPr>
-        <p:txBody>
-          <a:bodyPr wrap="square" rtlCol="0" anchor="ctr"/>
-          <a:lstStyle/>
-          <a:p>
-            <a:pPr marL="342900" indent="-342900">
-              <a:spcAft>
-                <a:spcPts val="500"/>
-              </a:spcAft>
-              <a:buSzPct val="100000"/>
-              <a:buChar char="•"/>
-            </a:pPr>
-            <a:r>
-              <a:rPr lang="en-US" sz="1300" dirty="0">
-                <a:solidFill>
-                  <a:srgbClr val="333333"/>
-                </a:solidFill>
-                <a:latin typeface="Arial" panose="020B0604020202020204" pitchFamily="34" charset="0"/>
-                <a:ea typeface="Arial" panose="020B0604020202020204" pitchFamily="34" charset="-122"/>
-                <a:cs typeface="Arial" panose="020B0604020202020204" pitchFamily="34" charset="-120"/>
-              </a:rPr>
-              <a:t>Fully automated parking management eliminates manual intervention.</a:t>
-            </a:r>
-            <a:endParaRPr lang="en-US" sz="1300" dirty="0"/>
-          </a:p>
-          <a:p>
-            <a:pPr marL="342900" indent="-342900">
-              <a:spcAft>
-                <a:spcPts val="500"/>
-              </a:spcAft>
-              <a:buSzPct val="100000"/>
-              <a:buChar char="•"/>
-            </a:pPr>
-            <a:r>
-              <a:rPr lang="en-US" sz="1300" dirty="0">
-                <a:solidFill>
-                  <a:srgbClr val="333333"/>
-                </a:solidFill>
-                <a:latin typeface="Arial" panose="020B0604020202020204" pitchFamily="34" charset="0"/>
-                <a:ea typeface="Arial" panose="020B0604020202020204" pitchFamily="34" charset="-122"/>
-                <a:cs typeface="Arial" panose="020B0604020202020204" pitchFamily="34" charset="-120"/>
-              </a:rPr>
-              <a:t>Real-time slot tracking ensures accurate occupancy visibility.</a:t>
-            </a:r>
-            <a:endParaRPr lang="en-US" sz="1300" dirty="0"/>
-          </a:p>
-          <a:p>
-            <a:pPr marL="342900" indent="-342900">
-              <a:spcAft>
-                <a:spcPts val="500"/>
-              </a:spcAft>
-              <a:buSzPct val="100000"/>
-              <a:buChar char="•"/>
-            </a:pPr>
-            <a:r>
-              <a:rPr lang="en-US" sz="1300" dirty="0">
-                <a:solidFill>
-                  <a:srgbClr val="333333"/>
-                </a:solidFill>
-                <a:latin typeface="Arial" panose="020B0604020202020204" pitchFamily="34" charset="0"/>
-                <a:ea typeface="Arial" panose="020B0604020202020204" pitchFamily="34" charset="-122"/>
-                <a:cs typeface="Arial" panose="020B0604020202020204" pitchFamily="34" charset="-120"/>
-              </a:rPr>
-              <a:t>Secure JWT-based authentication protects user data and system resources.</a:t>
-            </a:r>
-            <a:endParaRPr lang="en-US" sz="1300" dirty="0"/>
-          </a:p>
-          <a:p>
-            <a:pPr marL="342900" indent="-342900">
-              <a:spcAft>
-                <a:spcPts val="500"/>
-              </a:spcAft>
-              <a:buSzPct val="100000"/>
-              <a:buChar char="•"/>
-            </a:pPr>
-            <a:r>
-              <a:rPr lang="en-US" sz="1300" dirty="0">
-                <a:solidFill>
-                  <a:srgbClr val="333333"/>
-                </a:solidFill>
-                <a:latin typeface="Arial" panose="020B0604020202020204" pitchFamily="34" charset="0"/>
-                <a:ea typeface="Arial" panose="020B0604020202020204" pitchFamily="34" charset="-122"/>
-                <a:cs typeface="Arial" panose="020B0604020202020204" pitchFamily="34" charset="-120"/>
-              </a:rPr>
-              <a:t>Automatic billing generation and integrated payment processing improve accuracy.</a:t>
-            </a:r>
-            <a:endParaRPr lang="en-US" sz="1300" dirty="0"/>
-          </a:p>
-          <a:p>
-            <a:pPr marL="342900" indent="-342900">
-              <a:spcAft>
-                <a:spcPts val="500"/>
-              </a:spcAft>
-              <a:buSzPct val="100000"/>
-              <a:buChar char="•"/>
-            </a:pPr>
-            <a:r>
-              <a:rPr lang="en-US" sz="1300" dirty="0">
-                <a:solidFill>
-                  <a:srgbClr val="333333"/>
-                </a:solidFill>
-                <a:latin typeface="Arial" panose="020B0604020202020204" pitchFamily="34" charset="0"/>
-                <a:ea typeface="Arial" panose="020B0604020202020204" pitchFamily="34" charset="-122"/>
-                <a:cs typeface="Arial" panose="020B0604020202020204" pitchFamily="34" charset="-120"/>
-              </a:rPr>
-              <a:t>Enhanced user experience through seamless online reservation and digital receipts.</a:t>
-            </a:r>
-            <a:endParaRPr lang="en-US" sz="1300" dirty="0"/>
-          </a:p>
-          <a:p>
-            <a:pPr marL="342900" indent="-342900">
-              <a:spcAft>
-                <a:spcPts val="500"/>
-              </a:spcAft>
-              <a:buSzPct val="100000"/>
-              <a:buChar char="•"/>
-            </a:pPr>
-            <a:r>
-              <a:rPr lang="en-US" sz="1300" dirty="0">
-                <a:solidFill>
-                  <a:srgbClr val="333333"/>
-                </a:solidFill>
-                <a:latin typeface="Arial" panose="020B0604020202020204" pitchFamily="34" charset="0"/>
-                <a:ea typeface="Arial" panose="020B0604020202020204" pitchFamily="34" charset="-122"/>
-                <a:cs typeface="Arial" panose="020B0604020202020204" pitchFamily="34" charset="-120"/>
-              </a:rPr>
-              <a:t>Containerized deployment with Docker and Kubernetes ensures portability and resilience.</a:t>
-            </a:r>
-            <a:endParaRPr lang="en-US" sz="1300" dirty="0"/>
-          </a:p>
-          <a:p>
-            <a:pPr marL="342900" indent="-342900">
-              <a:spcAft>
-                <a:spcPts val="500"/>
-              </a:spcAft>
-              <a:buSzPct val="100000"/>
-              <a:buChar char="•"/>
-            </a:pPr>
-            <a:r>
-              <a:rPr lang="en-US" sz="1300" dirty="0">
-                <a:solidFill>
-                  <a:srgbClr val="333333"/>
-                </a:solidFill>
-                <a:latin typeface="Arial" panose="020B0604020202020204" pitchFamily="34" charset="0"/>
-                <a:ea typeface="Arial" panose="020B0604020202020204" pitchFamily="34" charset="-122"/>
-                <a:cs typeface="Arial" panose="020B0604020202020204" pitchFamily="34" charset="-120"/>
-              </a:rPr>
-              <a:t>Jenkins CI/CD automation accelerates software delivery and reduces deployment risk.</a:t>
-            </a:r>
-            <a:endParaRPr lang="en-US" sz="1300" dirty="0"/>
-          </a:p>
-        </p:txBody>
-      </p:sp>
-      <p:sp>
-        <p:nvSpPr>
-          <p:cNvPr id="7" name="Text 4"/>
-          <p:cNvSpPr/>
-          <p:nvPr/>
-        </p:nvSpPr>
-        <p:spPr>
-          <a:xfrm>
-            <a:off x="457200" y="2999232"/>
-            <a:ext cx="8229600" cy="365760"/>
-          </a:xfrm>
-          <a:prstGeom prst="rect">
-            <a:avLst/>
-          </a:prstGeom>
-          <a:noFill/>
-        </p:spPr>
-        <p:txBody>
-          <a:bodyPr wrap="square" lIns="0" tIns="0" rIns="0" bIns="0" rtlCol="0" anchor="ctr"/>
-          <a:lstStyle/>
-          <a:p>
-            <a:pPr marL="0" indent="0">
-              <a:buNone/>
-            </a:pPr>
-            <a:r>
-              <a:rPr lang="en-IN" altLang="en-US" sz="2200" b="1" dirty="0">
+          <p:cNvSpPr txBox="1"/>
+          <p:nvPr/>
+        </p:nvSpPr>
+        <p:spPr>
+          <a:xfrm>
+            <a:off x="400685" y="823087"/>
+            <a:ext cx="8229600" cy="347472"/>
+          </a:xfrm>
+          <a:prstGeom prst="rect">
+            <a:avLst/>
+          </a:prstGeom>
+          <a:noFill/>
+        </p:spPr>
+        <p:txBody>
+          <a:bodyPr wrap="square" lIns="0" tIns="0" rIns="0" bIns="0">
+            <a:spAutoFit/>
+          </a:bodyPr>
+          <a:lstStyle/>
+          <a:p>
+            <a:r>
+              <a:rPr sz="1800" b="1">
                 <a:solidFill>
                   <a:srgbClr val="0096CC"/>
                 </a:solidFill>
-                <a:latin typeface="Arial" panose="020B0604020202020204" pitchFamily="34" charset="0"/>
-                <a:ea typeface="Arial" panose="020B0604020202020204" pitchFamily="34" charset="-122"/>
-                <a:cs typeface="Arial" panose="020B0604020202020204" pitchFamily="34" charset="-120"/>
-              </a:rPr>
-              <a:t>Future Enhancement</a:t>
-            </a:r>
-            <a:r>
-              <a:rPr lang="en-US" sz="2200" b="1" dirty="0">
-                <a:solidFill>
-                  <a:srgbClr val="0096CC"/>
-                </a:solidFill>
-                <a:latin typeface="Arial" panose="020B0604020202020204" pitchFamily="34" charset="0"/>
-                <a:ea typeface="Arial" panose="020B0604020202020204" pitchFamily="34" charset="-122"/>
-                <a:cs typeface="Arial" panose="020B0604020202020204" pitchFamily="34" charset="-120"/>
-              </a:rPr>
-              <a:t>:</a:t>
-            </a:r>
-            <a:endParaRPr lang="en-US" sz="2200" dirty="0"/>
-          </a:p>
-        </p:txBody>
-      </p:sp>
-      <p:sp>
-        <p:nvSpPr>
-          <p:cNvPr id="8" name="Text 5"/>
-          <p:cNvSpPr/>
-          <p:nvPr/>
-        </p:nvSpPr>
-        <p:spPr>
-          <a:xfrm>
-            <a:off x="457200" y="3280918"/>
-            <a:ext cx="8229600" cy="1371600"/>
-          </a:xfrm>
-          <a:prstGeom prst="rect">
-            <a:avLst/>
-          </a:prstGeom>
-          <a:noFill/>
-        </p:spPr>
-        <p:txBody>
-          <a:bodyPr wrap="square" rtlCol="0" anchor="ctr"/>
-          <a:lstStyle/>
-          <a:p>
-            <a:pPr marL="342900" indent="-342900">
-              <a:spcAft>
-                <a:spcPts val="300"/>
-              </a:spcAft>
-              <a:buSzPct val="100000"/>
-              <a:buChar char="•"/>
-            </a:pPr>
-            <a:r>
-              <a:rPr lang="en-US" sz="1250" dirty="0">
-                <a:solidFill>
-                  <a:srgbClr val="333333"/>
-                </a:solidFill>
-                <a:latin typeface="Arial" panose="020B0604020202020204" pitchFamily="34" charset="0"/>
-                <a:ea typeface="Arial" panose="020B0604020202020204" pitchFamily="34" charset="-122"/>
-                <a:cs typeface="Arial" panose="020B0604020202020204" pitchFamily="34" charset="-120"/>
-              </a:rPr>
-              <a:t>Higher infrastructure resource consumption due to Docker and Kubernetes overhead.</a:t>
-            </a:r>
-            <a:endParaRPr lang="en-US" sz="1250" dirty="0"/>
-          </a:p>
-          <a:p>
-            <a:pPr marL="342900" indent="-342900">
-              <a:spcAft>
-                <a:spcPts val="300"/>
-              </a:spcAft>
-              <a:buSzPct val="100000"/>
-              <a:buChar char="•"/>
-            </a:pPr>
-            <a:r>
-              <a:rPr lang="en-US" sz="1250" dirty="0">
-                <a:solidFill>
-                  <a:srgbClr val="333333"/>
-                </a:solidFill>
-                <a:latin typeface="Arial" panose="020B0604020202020204" pitchFamily="34" charset="0"/>
-                <a:ea typeface="Arial" panose="020B0604020202020204" pitchFamily="34" charset="-122"/>
-                <a:cs typeface="Arial" panose="020B0604020202020204" pitchFamily="34" charset="-120"/>
-              </a:rPr>
-              <a:t>Requires ongoing maintenance and periodic updates to remain secure and stable.</a:t>
-            </a:r>
-            <a:endParaRPr lang="en-US" sz="1250" dirty="0"/>
-          </a:p>
-          <a:p>
-            <a:pPr marL="342900" indent="-342900">
-              <a:spcAft>
-                <a:spcPts val="300"/>
-              </a:spcAft>
-              <a:buSzPct val="100000"/>
-              <a:buChar char="•"/>
-            </a:pPr>
-            <a:r>
-              <a:rPr lang="en-US" sz="1250" dirty="0">
-                <a:solidFill>
-                  <a:srgbClr val="333333"/>
-                </a:solidFill>
-                <a:latin typeface="Arial" panose="020B0604020202020204" pitchFamily="34" charset="0"/>
-                <a:ea typeface="Arial" panose="020B0604020202020204" pitchFamily="34" charset="-122"/>
-                <a:cs typeface="Arial" panose="020B0604020202020204" pitchFamily="34" charset="-120"/>
-              </a:rPr>
-              <a:t>No IoT or RFID integration is available in the current version.</a:t>
-            </a:r>
-            <a:endParaRPr lang="en-US" sz="1250" dirty="0"/>
-          </a:p>
-          <a:p>
-            <a:pPr marL="342900" indent="-342900">
-              <a:spcAft>
-                <a:spcPts val="300"/>
-              </a:spcAft>
-              <a:buSzPct val="100000"/>
-              <a:buChar char="•"/>
-            </a:pPr>
-            <a:r>
-              <a:rPr lang="en-US" sz="1250" dirty="0">
-                <a:solidFill>
-                  <a:srgbClr val="333333"/>
-                </a:solidFill>
-                <a:latin typeface="Arial" panose="020B0604020202020204" pitchFamily="34" charset="0"/>
-                <a:ea typeface="Arial" panose="020B0604020202020204" pitchFamily="34" charset="-122"/>
-                <a:cs typeface="Arial" panose="020B0604020202020204" pitchFamily="34" charset="-120"/>
-              </a:rPr>
-              <a:t>The database remains a single point of failure within the current project deployment configuration.</a:t>
-            </a:r>
-            <a:endParaRPr lang="en-US" sz="1250" dirty="0"/>
-          </a:p>
-        </p:txBody>
-      </p:sp>
+                <a:latin typeface="Arial" panose="020B0604020202020204"/>
+              </a:rPr>
+              <a:t>Jenkins CI/CD Build Pipeline</a:t>
+            </a:r>
+            <a:endParaRPr sz="1800" b="1">
+              <a:solidFill>
+                <a:srgbClr val="0096CC"/>
+              </a:solidFill>
+              <a:latin typeface="Arial" panose="020B0604020202020204"/>
+            </a:endParaRPr>
+          </a:p>
+        </p:txBody>
+      </p:sp>
+      <p:pic>
+        <p:nvPicPr>
+          <p:cNvPr id="7" name="Picture 6" descr="Jenkins.PNG"/>
+          <p:cNvPicPr>
+            <a:picLocks noChangeAspect="1"/>
+          </p:cNvPicPr>
+          <p:nvPr/>
+        </p:nvPicPr>
+        <p:blipFill>
+          <a:blip r:embed="rId2"/>
+          <a:stretch>
+            <a:fillRect/>
+          </a:stretch>
+        </p:blipFill>
+        <p:spPr>
+          <a:xfrm>
+            <a:off x="1699215" y="1403604"/>
+            <a:ext cx="5745568" cy="3017520"/>
+          </a:xfrm>
+          <a:prstGeom prst="rect">
+            <a:avLst/>
+          </a:prstGeom>
+        </p:spPr>
+      </p:pic>
     </p:spTree>
   </p:cSld>
   <p:clrMapOvr>
@@ -5899,8 +5626,228 @@
         </p:blipFill>
         <p:spPr>
           <a:xfrm>
-            <a:off x="3504937" y="1403604"/>
-            <a:ext cx="2134124" cy="3017520"/>
+            <a:off x="1828800" y="1403604"/>
+            <a:ext cx="5486400" cy="3017520"/>
+          </a:xfrm>
+          <a:prstGeom prst="rect">
+            <a:avLst/>
+          </a:prstGeom>
+        </p:spPr>
+      </p:pic>
+    </p:spTree>
+  </p:cSld>
+  <p:clrMapOvr>
+    <a:masterClrMapping/>
+  </p:clrMapOvr>
+</p:sld>
+</file>
+
+<file path=ppt/slides/slide22.xml><?xml version="1.0" encoding="utf-8"?>
+<p:sld xmlns:a="http://schemas.openxmlformats.org/drawingml/2006/main" xmlns:p="http://schemas.openxmlformats.org/presentationml/2006/main" xmlns:r="http://schemas.openxmlformats.org/officeDocument/2006/relationships">
+  <p:cSld>
+    <p:bg>
+      <p:bgPr>
+        <a:solidFill>
+          <a:srgbClr val="FFFFFF"/>
+        </a:solidFill>
+        <a:effectLst/>
+      </p:bgPr>
+    </p:bg>
+    <p:spTree>
+      <p:nvGrpSpPr>
+        <p:cNvPr id="1" name=""/>
+        <p:cNvGrpSpPr/>
+        <p:nvPr/>
+      </p:nvGrpSpPr>
+      <p:grpSpPr/>
+      <p:pic>
+        <p:nvPicPr>
+          <p:cNvPr id="2" name="Picture 1" descr="image.png"/>
+          <p:cNvPicPr>
+            <a:picLocks noChangeAspect="1"/>
+          </p:cNvPicPr>
+          <p:nvPr/>
+        </p:nvPicPr>
+        <p:blipFill>
+          <a:blip r:embed="rId2"/>
+          <a:stretch>
+            <a:fillRect/>
+          </a:stretch>
+        </p:blipFill>
+        <p:spPr>
+          <a:xfrm>
+            <a:off x="274320" y="4553712"/>
+            <a:ext cx="1005840" cy="402336"/>
+          </a:xfrm>
+          <a:prstGeom prst="rect">
+            <a:avLst/>
+          </a:prstGeom>
+        </p:spPr>
+      </p:pic>
+      <p:sp>
+        <p:nvSpPr>
+          <p:cNvPr id="3" name="Text 0"/>
+          <p:cNvSpPr txBox="1"/>
+          <p:nvPr/>
+        </p:nvSpPr>
+        <p:spPr>
+          <a:xfrm>
+            <a:off x="3200400" y="4910328"/>
+            <a:ext cx="2743200" cy="201168"/>
+          </a:xfrm>
+          <a:prstGeom prst="rect">
+            <a:avLst/>
+          </a:prstGeom>
+          <a:noFill/>
+        </p:spPr>
+        <p:txBody>
+          <a:bodyPr wrap="square">
+            <a:spAutoFit/>
+          </a:bodyPr>
+          <a:lstStyle/>
+          <a:p>
+            <a:pPr algn="ctr">
+              <a:defRPr/>
+            </a:pPr>
+            <a:r>
+              <a:rPr sz="800">
+                <a:solidFill>
+                  <a:srgbClr val="888888"/>
+                </a:solidFill>
+                <a:latin typeface="Arial"/>
+              </a:rPr>
+              <a:t>General - RPS Data</a:t>
+            </a:r>
+          </a:p>
+        </p:txBody>
+      </p:sp>
+      <p:sp>
+        <p:nvSpPr>
+          <p:cNvPr id="4" name="Text 1"/>
+          <p:cNvSpPr txBox="1"/>
+          <p:nvPr/>
+        </p:nvSpPr>
+        <p:spPr>
+          <a:xfrm>
+            <a:off x="5029200" y="4910328"/>
+            <a:ext cx="3931920" cy="201168"/>
+          </a:xfrm>
+          <a:prstGeom prst="rect">
+            <a:avLst/>
+          </a:prstGeom>
+          <a:noFill/>
+        </p:spPr>
+        <p:txBody>
+          <a:bodyPr wrap="square">
+            <a:spAutoFit/>
+          </a:bodyPr>
+          <a:lstStyle/>
+          <a:p>
+            <a:pPr algn="r">
+              <a:defRPr/>
+            </a:pPr>
+            <a:r>
+              <a:rPr sz="800">
+                <a:solidFill>
+                  <a:srgbClr val="888888"/>
+                </a:solidFill>
+                <a:latin typeface="Arial"/>
+              </a:rPr>
+              <a:t>2026 - RPS Consulting all rights reserved    2</a:t>
+            </a:r>
+          </a:p>
+        </p:txBody>
+      </p:sp>
+      <p:sp>
+        <p:nvSpPr>
+          <p:cNvPr id="5" name="Text 2"/>
+          <p:cNvSpPr txBox="1"/>
+          <p:nvPr/>
+        </p:nvSpPr>
+        <p:spPr>
+          <a:xfrm>
+            <a:off x="457200" y="228600"/>
+            <a:ext cx="8229600" cy="438912"/>
+          </a:xfrm>
+          <a:prstGeom prst="rect">
+            <a:avLst/>
+          </a:prstGeom>
+          <a:noFill/>
+        </p:spPr>
+        <p:txBody>
+          <a:bodyPr wrap="square" lIns="0" rIns="0" tIns="0" bIns="0">
+            <a:spAutoFit/>
+          </a:bodyPr>
+          <a:lstStyle/>
+          <a:p>
+            <a:pPr>
+              <a:defRPr/>
+            </a:pPr>
+            <a:r>
+              <a:rPr sz="2600" b="1">
+                <a:solidFill>
+                  <a:srgbClr val="0096CC"/>
+                </a:solidFill>
+                <a:latin typeface="Arial"/>
+              </a:rPr>
+              <a:t>Smart Parking Management System</a:t>
+            </a:r>
+          </a:p>
+        </p:txBody>
+      </p:sp>
+      <p:sp>
+        <p:nvSpPr>
+          <p:cNvPr id="6" name="Text 3"/>
+          <p:cNvSpPr txBox="1"/>
+          <p:nvPr/>
+        </p:nvSpPr>
+        <p:spPr>
+          <a:xfrm>
+            <a:off x="400685" y="823087"/>
+            <a:ext cx="8229600" cy="347472"/>
+          </a:xfrm>
+          <a:prstGeom prst="rect">
+            <a:avLst/>
+          </a:prstGeom>
+          <a:noFill/>
+        </p:spPr>
+        <p:txBody>
+          <a:bodyPr wrap="square" lIns="0" rIns="0" tIns="0" bIns="0">
+            <a:spAutoFit/>
+          </a:bodyPr>
+          <a:lstStyle/>
+          <a:p>
+            <a:pPr/>
+            <a:r>
+              <a:rPr sz="1800" b="1">
+                <a:solidFill>
+                  <a:srgbClr val="0096CC"/>
+                </a:solidFill>
+                <a:latin typeface="Arial"/>
+              </a:rPr>
+              <a:t>Entity Relationship Diagram</a:t>
+            </a:r>
+          </a:p>
+        </p:txBody>
+      </p:sp>
+      <p:pic>
+        <p:nvPicPr>
+          <p:cNvPr id="7" name="Picture 6" descr="ER_page_1.png"/>
+          <p:cNvPicPr>
+            <a:picLocks noChangeAspect="1"/>
+          </p:cNvPicPr>
+          <p:nvPr/>
+        </p:nvPicPr>
+        <p:blipFill>
+          <a:blip r:embed="rId3"/>
+          <a:stretch>
+            <a:fillRect/>
+          </a:stretch>
+        </p:blipFill>
+        <p:spPr>
+          <a:xfrm>
+            <a:off x="1828800" y="1403604"/>
+            <a:ext cx="5486400" cy="3017520"/>
           </a:xfrm>
           <a:prstGeom prst="rect">
             <a:avLst/>

</xml_diff>